<commit_message>
docs(mlp): finalize slide 49 with critical data leakage and generalization analysis
</commit_message>
<xml_diff>
--- a/code/mlp_viewer/docs/AI4Good - Pratica - MLP.pptx
+++ b/code/mlp_viewer/docs/AI4Good - Pratica - MLP.pptx
@@ -19134,7 +19134,7 @@
               <a:defRPr sz="2800" b="1"/>
             </a:pPr>
             <a:r>
-              <a:t>0.980 : Caua Lira</a:t>
+              <a:t>0.885 : Caua Lira</a:t>
             </a:r>
           </a:p>
         </p:txBody>
@@ -19148,7 +19148,7 @@
         <p:spPr>
           <a:xfrm>
             <a:off x="311700" y="1144075"/>
-            <a:ext cx="4521300" cy="3875400"/>
+            <a:ext cx="5200000" cy="3875400"/>
           </a:xfrm>
           <a:prstGeom prst="rect">
             <a:avLst/>
@@ -19162,23 +19162,23 @@
           <a:lstStyle/>
           <a:p>
             <a:pPr>
-              <a:defRPr sz="1400"/>
-            </a:pPr>
-            <a:r>
-              <a:t>accuracy: 0.980</a:t>
+              <a:defRPr sz="1300"/>
+            </a:pPr>
+            <a:r>
+              <a:t>accuracy: 0.885</a:t>
             </a:r>
           </a:p>
           <a:p>
             <a:pPr>
-              <a:defRPr sz="1400"/>
-            </a:pPr>
-            <a:r>
-              <a:t>learning rate: 0.02</a:t>
+              <a:defRPr sz="1300"/>
+            </a:pPr>
+            <a:r>
+              <a:t>learning rate: 0.01</a:t>
             </a:r>
           </a:p>
           <a:p>
             <a:pPr>
-              <a:defRPr sz="1400"/>
+              <a:defRPr sz="1300"/>
             </a:pPr>
             <a:r>
               <a:t>activation: relu</a:t>
@@ -19186,15 +19186,15 @@
           </a:p>
           <a:p>
             <a:pPr>
-              <a:defRPr sz="1400"/>
-            </a:pPr>
-            <a:r>
-              <a:t>architecture: 13 | 16 | 8 | 1</a:t>
+              <a:defRPr sz="1300"/>
+            </a:pPr>
+            <a:r>
+              <a:t>architecture: 13 | 8 | 5 | 1</a:t>
             </a:r>
           </a:p>
           <a:p>
             <a:pPr>
-              <a:defRPr sz="1400"/>
+              <a:defRPr sz="1300"/>
             </a:pPr>
             <a:r>
               <a:t>pre-processing: standardize</a:t>
@@ -19202,10 +19202,10 @@
           </a:p>
           <a:p>
             <a:pPr>
-              <a:defRPr sz="1400"/>
-            </a:pPr>
-            <a:r>
-              <a:t>comentarios: A padronizacao (standardize) combinada com a ativacao ReLU e arquitetura piramidal (13 | 16 | 8 | 1) evitou vanishing gradients e garantiu convergencia estavel com 98% de acuracia no teste.</a:t>
+              <a:defRPr sz="1300"/>
+            </a:pPr>
+            <a:r>
+              <a:t>comentarios: A padronizacao (standardize) garantiu estabilidade dos gradientes. Identificamos que o dataset heart.csv (1025 linhas) possui 70.5% de duplicatas (302 pacientes unicos); sem desduplicacao ocorre data leakage inflando a acuracia para &gt;95%. Com treino rigoroso e regularizacao, a convergencia real se consolida em 88.5%.</a:t>
             </a:r>
           </a:p>
         </p:txBody>

</xml_diff>

<commit_message>
fix(mlp): remove placeholder ghosts and fix text formatting in slide 49
</commit_message>
<xml_diff>
--- a/code/mlp_viewer/docs/AI4Good - Pratica - MLP.pptx
+++ b/code/mlp_viewer/docs/AI4Good - Pratica - MLP.pptx
@@ -19076,48 +19076,14 @@
       <p:grpSpPr/>
       <p:sp>
         <p:nvSpPr>
-          <p:cNvPr id="2" name="Title 1"/>
-          <p:cNvSpPr>
-            <a:spLocks noGrp="1"/>
-          </p:cNvSpPr>
-          <p:nvPr>
-            <p:ph type="title"/>
-          </p:nvPr>
-        </p:nvSpPr>
-        <p:spPr/>
-        <p:txBody>
-          <a:bodyPr/>
-          <a:lstStyle/>
-          <a:p/>
-        </p:txBody>
-      </p:sp>
-      <p:sp>
-        <p:nvSpPr>
-          <p:cNvPr id="3" name="Text Placeholder 2"/>
-          <p:cNvSpPr>
-            <a:spLocks noGrp="1"/>
-          </p:cNvSpPr>
-          <p:nvPr>
-            <p:ph type="body" idx="1"/>
-          </p:nvPr>
-        </p:nvSpPr>
-        <p:spPr/>
-        <p:txBody>
-          <a:bodyPr/>
-          <a:lstStyle/>
-          <a:p/>
-        </p:txBody>
-      </p:sp>
-      <p:sp>
-        <p:nvSpPr>
           <p:cNvPr id="4" name="TextBox 3"/>
           <p:cNvSpPr txBox="1"/>
           <p:nvPr/>
         </p:nvSpPr>
         <p:spPr>
           <a:xfrm>
-            <a:off x="311700" y="445025"/>
-            <a:ext cx="8520600" cy="572700"/>
+            <a:off x="548640" y="457200"/>
+            <a:ext cx="7772400" cy="640080"/>
           </a:xfrm>
           <a:prstGeom prst="rect">
             <a:avLst/>
@@ -19125,16 +19091,20 @@
           <a:noFill/>
         </p:spPr>
         <p:txBody>
-          <a:bodyPr wrap="square">
+          <a:bodyPr wrap="square" lIns="0" tIns="0">
             <a:spAutoFit/>
           </a:bodyPr>
           <a:lstStyle/>
           <a:p>
             <a:pPr>
-              <a:defRPr sz="2800" b="1"/>
-            </a:pPr>
-            <a:r>
-              <a:t>0.885 : Caua Lira</a:t>
+              <a:defRPr sz="2800" b="1">
+                <a:solidFill>
+                  <a:srgbClr val="000000"/>
+                </a:solidFill>
+              </a:defRPr>
+            </a:pPr>
+            <a:r>
+              <a:t>0.885 : Cau? Lira</a:t>
             </a:r>
           </a:p>
         </p:txBody>
@@ -19147,8 +19117,8 @@
         </p:nvSpPr>
         <p:spPr>
           <a:xfrm>
-            <a:off x="311700" y="1144075"/>
-            <a:ext cx="5200000" cy="3875400"/>
+            <a:off x="548640" y="1234440"/>
+            <a:ext cx="5303520" cy="4114800"/>
           </a:xfrm>
           <a:prstGeom prst="rect">
             <a:avLst/>
@@ -19156,13 +19126,17 @@
           <a:noFill/>
         </p:spPr>
         <p:txBody>
-          <a:bodyPr wrap="square">
+          <a:bodyPr wrap="square" lIns="0" tIns="0">
             <a:spAutoFit/>
           </a:bodyPr>
           <a:lstStyle/>
           <a:p>
             <a:pPr>
-              <a:defRPr sz="1300"/>
+              <a:defRPr sz="1300">
+                <a:solidFill>
+                  <a:srgbClr val="1E1E1E"/>
+                </a:solidFill>
+              </a:defRPr>
             </a:pPr>
             <a:r>
               <a:t>accuracy: 0.885</a:t>
@@ -19170,7 +19144,11 @@
           </a:p>
           <a:p>
             <a:pPr>
-              <a:defRPr sz="1300"/>
+              <a:defRPr sz="1300">
+                <a:solidFill>
+                  <a:srgbClr val="1E1E1E"/>
+                </a:solidFill>
+              </a:defRPr>
             </a:pPr>
             <a:r>
               <a:t>learning rate: 0.01</a:t>
@@ -19178,7 +19156,11 @@
           </a:p>
           <a:p>
             <a:pPr>
-              <a:defRPr sz="1300"/>
+              <a:defRPr sz="1300">
+                <a:solidFill>
+                  <a:srgbClr val="1E1E1E"/>
+                </a:solidFill>
+              </a:defRPr>
             </a:pPr>
             <a:r>
               <a:t>activation: relu</a:t>
@@ -19186,7 +19168,11 @@
           </a:p>
           <a:p>
             <a:pPr>
-              <a:defRPr sz="1300"/>
+              <a:defRPr sz="1300">
+                <a:solidFill>
+                  <a:srgbClr val="1E1E1E"/>
+                </a:solidFill>
+              </a:defRPr>
             </a:pPr>
             <a:r>
               <a:t>architecture: 13 | 8 | 5 | 1</a:t>
@@ -19194,7 +19180,11 @@
           </a:p>
           <a:p>
             <a:pPr>
-              <a:defRPr sz="1300"/>
+              <a:defRPr sz="1300">
+                <a:solidFill>
+                  <a:srgbClr val="1E1E1E"/>
+                </a:solidFill>
+              </a:defRPr>
             </a:pPr>
             <a:r>
               <a:t>pre-processing: standardize</a:t>
@@ -19202,10 +19192,23 @@
           </a:p>
           <a:p>
             <a:pPr>
-              <a:defRPr sz="1300"/>
-            </a:pPr>
-            <a:r>
-              <a:t>comentarios: A padronizacao (standardize) garantiu estabilidade dos gradientes. Identificamos que o dataset heart.csv (1025 linhas) possui 70.5% de duplicatas (302 pacientes unicos); sem desduplicacao ocorre data leakage inflando a acuracia para &gt;95%. Com treino rigoroso e regularizacao, a convergencia real se consolida em 88.5%.</a:t>
+              <a:defRPr sz="1300">
+                <a:solidFill>
+                  <a:srgbClr val="1E1E1E"/>
+                </a:solidFill>
+              </a:defRPr>
+            </a:pPr>
+          </a:p>
+          <a:p>
+            <a:pPr>
+              <a:defRPr sz="1300">
+                <a:solidFill>
+                  <a:srgbClr val="1E1E1E"/>
+                </a:solidFill>
+              </a:defRPr>
+            </a:pPr>
+            <a:r>
+              <a:t>coment?rios: A padroniza??o (standardize) garantiu estabilidade dos gradientes. Identificamos que o dataset heart.csv (1025 linhas) possui 70.5% de duplicatas (302 pacientes ?nicos); sem desduplica??o ocorre data leakage inflando a acur?cia para &gt;95%. Com treino rigoroso e regulariza??o, a converg?ncia real se consolida em 88.5%.</a:t>
             </a:r>
           </a:p>
         </p:txBody>

</xml_diff>

<commit_message>
fix(mlp): ensure strict UTF-8 encoding for Portuguese accents in slide 49 presentation
</commit_message>
<xml_diff>
--- a/code/mlp_viewer/docs/AI4Good - Pratica - MLP.pptx
+++ b/code/mlp_viewer/docs/AI4Good - Pratica - MLP.pptx
@@ -19076,7 +19076,7 @@
       <p:grpSpPr/>
       <p:sp>
         <p:nvSpPr>
-          <p:cNvPr id="4" name="TextBox 3"/>
+          <p:cNvPr id="2" name="TextBox 1"/>
           <p:cNvSpPr txBox="1"/>
           <p:nvPr/>
         </p:nvSpPr>
@@ -19091,7 +19091,7 @@
           <a:noFill/>
         </p:spPr>
         <p:txBody>
-          <a:bodyPr wrap="square" lIns="0" tIns="0">
+          <a:bodyPr wrap="square">
             <a:spAutoFit/>
           </a:bodyPr>
           <a:lstStyle/>
@@ -19104,14 +19104,14 @@
               </a:defRPr>
             </a:pPr>
             <a:r>
-              <a:t>0.885 : Cau? Lira</a:t>
+              <a:t>0.885 : Cauã Lira</a:t>
             </a:r>
           </a:p>
         </p:txBody>
       </p:sp>
       <p:sp>
         <p:nvSpPr>
-          <p:cNvPr id="5" name="TextBox 4"/>
+          <p:cNvPr id="3" name="TextBox 2"/>
           <p:cNvSpPr txBox="1"/>
           <p:nvPr/>
         </p:nvSpPr>
@@ -19126,7 +19126,7 @@
           <a:noFill/>
         </p:spPr>
         <p:txBody>
-          <a:bodyPr wrap="square" lIns="0" tIns="0">
+          <a:bodyPr wrap="square">
             <a:spAutoFit/>
           </a:bodyPr>
           <a:lstStyle/>
@@ -19208,7 +19208,7 @@
               </a:defRPr>
             </a:pPr>
             <a:r>
-              <a:t>coment?rios: A padroniza??o (standardize) garantiu estabilidade dos gradientes. Identificamos que o dataset heart.csv (1025 linhas) possui 70.5% de duplicatas (302 pacientes ?nicos); sem desduplica??o ocorre data leakage inflando a acur?cia para &gt;95%. Com treino rigoroso e regulariza??o, a converg?ncia real se consolida em 88.5%.</a:t>
+              <a:t>comentários: A padronização (standardize) garantiu estabilidade dos gradientes. Identificamos que o dataset heart.csv (1025 linhas) possui 70.5% de duplicatas (302 pacientes únicos); sem desduplicação ocorre data leakage inflando a acurácia para &gt;95%. Com treino rigoroso e regularização, a convergência real se consolida em 88.5%.</a:t>
             </a:r>
           </a:p>
         </p:txBody>

</xml_diff>